<commit_message>
Remove emissions fallback waterfall from core model
Co-authored-by: Roja Rao <rojaraod@users.noreply.github.com>
</commit_message>
<xml_diff>
--- a/docs/supply_chain_emissions_forecasting_20_slide_deck.pptx
+++ b/docs/supply_chain_emissions_forecasting_20_slide_deck.pptx
@@ -3386,7 +3386,7 @@
               </a:defRPr>
             </a:pPr>
             <a:r>
-              <a:t>Supplier target, industry fallback, and historical trend pathways</a:t>
+              <a:t>Supplier target, industry target, and historical trend pathways</a:t>
             </a:r>
           </a:p>
         </p:txBody>
@@ -3522,7 +3522,7 @@
               </a:defRPr>
             </a:pPr>
             <a:r>
-              <a:t>Use when supplier-specific target data is missing.</a:t>
+              <a:t>Use when supplier-specific target data is missing but actual supplier emissions are available.</a:t>
             </a:r>
           </a:p>
           <a:p>
@@ -4026,7 +4026,7 @@
               </a:defRPr>
             </a:pPr>
             <a:r>
-              <a:t>Best used as a data-driven fallback with confidence caveats.</a:t>
+              <a:t>Best used as a data-driven trend method with confidence caveats.</a:t>
             </a:r>
           </a:p>
         </p:txBody>
@@ -4094,7 +4094,7 @@
               </a:defRPr>
             </a:pPr>
             <a:r>
-              <a:t>Prevents blank forecasts and highlights suppliers needing better target data.</a:t>
+              <a:t>Uses actual emissions history to forecast suppliers without target pathways.</a:t>
             </a:r>
           </a:p>
         </p:txBody>
@@ -4479,7 +4479,7 @@
                         </a:defRPr>
                       </a:pPr>
                       <a:r>
-                        <a:t>Reported else scopes else spend x factor else revenue x intensity else industry estimate</a:t>
+                        <a:t>Use supplied Total_Emission_Value or Reported_Emissions</a:t>
                       </a:r>
                     </a:p>
                   </a:txBody>
@@ -4993,7 +4993,7 @@
               </a:defRPr>
             </a:pPr>
             <a:r>
-              <a:t>Emissions inputs: reported emissions, scopes, spend, revenue, total emission value.</a:t>
+              <a:t>Emissions inputs: reported emissions, total emission value, scopes, spend, revenue.</a:t>
             </a:r>
           </a:p>
           <a:p>
@@ -5009,7 +5009,7 @@
               </a:defRPr>
             </a:pPr>
             <a:r>
-              <a:t>Audit flags: source, fallback, data quality, missing parameters, validation.</a:t>
+              <a:t>Audit flags: emissions source, data availability, data quality, missing parameters, validation.</a:t>
             </a:r>
           </a:p>
           <a:p>
@@ -6050,7 +6050,7 @@
               </a:defRPr>
             </a:pPr>
             <a:r>
-              <a:t>Clean missing values</a:t>
+              <a:t>Validate emissions inputs</a:t>
             </a:r>
           </a:p>
         </p:txBody>
@@ -6161,7 +6161,7 @@
               </a:defRPr>
             </a:pPr>
             <a:r>
-              <a:t>Calculate emissions and flags</a:t>
+              <a:t>Create quality and source flags</a:t>
             </a:r>
           </a:p>
         </p:txBody>
@@ -6658,7 +6658,7 @@
               </a:defRPr>
             </a:pPr>
             <a:r>
-              <a:t>Use flags to make fallback logic visible to business users.</a:t>
+              <a:t>Use flags to make emissions availability and validation status visible to business users.</a:t>
             </a:r>
           </a:p>
           <a:p>
@@ -6742,7 +6742,7 @@
               </a:defRPr>
             </a:pPr>
             <a:r>
-              <a:t>=IF([@[Reported_Emissions]]&lt;&gt;"",[@[Reported_Emissions]], fallback logic)</a:t>
+              <a:t>=IF([@[Reported_Emissions]]&lt;&gt;"",[@[Reported_Emissions]],"Missing Emissions")</a:t>
             </a:r>
           </a:p>
         </p:txBody>
@@ -7522,7 +7522,7 @@
                         </a:defRPr>
                       </a:pPr>
                       <a:r>
-                        <a:t>Source, fallback, missing fields</a:t>
+                        <a:t>Source, availability, missing fields</a:t>
                       </a:r>
                     </a:p>
                   </a:txBody>
@@ -7973,7 +7973,7 @@
               </a:defRPr>
             </a:pPr>
             <a:r>
-              <a:t>Explicit fallback sequence, source flags, validation flags, and method flags.</a:t>
+              <a:t>Direct emissions validation, source flags, validation flags, and method flags.</a:t>
             </a:r>
           </a:p>
         </p:txBody>
@@ -8080,7 +8080,7 @@
               </a:defRPr>
             </a:pPr>
             <a:r>
-              <a:t>Recommended validation: missing emissions, negative values, target year before baseline, low confidence, outliers, missing factors.</a:t>
+              <a:t>Recommended validation: missing emissions, negative values, target year before baseline, low confidence, and outliers.</a:t>
             </a:r>
           </a:p>
           <a:p>
@@ -10423,7 +10423,7 @@
               </a:defRPr>
             </a:pPr>
             <a:r>
-              <a:t>Emission calc</a:t>
+              <a:t>Emission input</a:t>
             </a:r>
           </a:p>
           <a:p>
@@ -10436,7 +10436,7 @@
               </a:defRPr>
             </a:pPr>
             <a:r>
-              <a:t>Reported, scope, spend, revenue, industry fallback</a:t>
+              <a:t>Use supplied historical and current emissions</a:t>
             </a:r>
           </a:p>
         </p:txBody>
@@ -10824,7 +10824,7 @@
               </a:defRPr>
             </a:pPr>
             <a:r>
-              <a:t>Each output record keeps its source, method, quality, and validation flags for traceability.</a:t>
+              <a:t>Each output record keeps its emissions source, forecast method, quality, and validation flags for traceability.</a:t>
             </a:r>
           </a:p>
         </p:txBody>
@@ -11344,7 +11344,7 @@
                         </a:defRPr>
                       </a:pPr>
                       <a:r>
-                        <a:t>Fallback targets and estimates</a:t>
+                        <a:t>Industry pathway assumptions</a:t>
                       </a:r>
                     </a:p>
                   </a:txBody>
@@ -11518,7 +11518,7 @@
               </a:defRPr>
             </a:pPr>
             <a:r>
-              <a:t>Total Emission Value Fallback Logic</a:t>
+              <a:t>Direct Emissions Input Validation</a:t>
             </a:r>
           </a:p>
         </p:txBody>
@@ -11616,7 +11616,7 @@
               </a:defRPr>
             </a:pPr>
             <a:r>
-              <a:t>P1</a:t>
+              <a:t>1</a:t>
             </a:r>
           </a:p>
           <a:p>
@@ -11629,7 +11629,7 @@
               </a:defRPr>
             </a:pPr>
             <a:r>
-              <a:t>Reported emissions</a:t>
+              <a:t>Load supplier emissions</a:t>
             </a:r>
           </a:p>
         </p:txBody>
@@ -11727,7 +11727,7 @@
               </a:defRPr>
             </a:pPr>
             <a:r>
-              <a:t>P2</a:t>
+              <a:t>2</a:t>
             </a:r>
           </a:p>
           <a:p>
@@ -11740,7 +11740,7 @@
               </a:defRPr>
             </a:pPr>
             <a:r>
-              <a:t>Scope 1 + 2 + 3</a:t>
+              <a:t>Validate non-negative values</a:t>
             </a:r>
           </a:p>
         </p:txBody>
@@ -11838,7 +11838,7 @@
               </a:defRPr>
             </a:pPr>
             <a:r>
-              <a:t>P3</a:t>
+              <a:t>3</a:t>
             </a:r>
           </a:p>
           <a:p>
@@ -11851,7 +11851,7 @@
               </a:defRPr>
             </a:pPr>
             <a:r>
-              <a:t>Spend x factor</a:t>
+              <a:t>Check completeness</a:t>
             </a:r>
           </a:p>
         </p:txBody>
@@ -11949,7 +11949,7 @@
               </a:defRPr>
             </a:pPr>
             <a:r>
-              <a:t>P4</a:t>
+              <a:t>4</a:t>
             </a:r>
           </a:p>
           <a:p>
@@ -11962,7 +11962,7 @@
               </a:defRPr>
             </a:pPr>
             <a:r>
-              <a:t>Revenue x intensity</a:t>
+              <a:t>Flag outliers</a:t>
             </a:r>
           </a:p>
         </p:txBody>
@@ -12060,7 +12060,7 @@
               </a:defRPr>
             </a:pPr>
             <a:r>
-              <a:t>P5/P6</a:t>
+              <a:t>5</a:t>
             </a:r>
           </a:p>
           <a:p>
@@ -12073,7 +12073,7 @@
               </a:defRPr>
             </a:pPr>
             <a:r>
-              <a:t>Industry estimate or missing</a:t>
+              <a:t>Use in forecast</a:t>
             </a:r>
           </a:p>
         </p:txBody>
@@ -12112,7 +12112,7 @@
               </a:defRPr>
             </a:pPr>
             <a:r>
-              <a:t>Formula: use the highest-quality available input, then move through increasingly estimated fallbacks.</a:t>
+              <a:t>The 6-level waterfall is not required because all suppliers have historical and current emissions.</a:t>
             </a:r>
           </a:p>
           <a:p>
@@ -12128,7 +12128,7 @@
               </a:defRPr>
             </a:pPr>
             <a:r>
-              <a:t>Every record receives Emission_Source_Flag, Fallback_Applied_Flag, Data_Quality_Flag, Missing_Parameter_Flag, Confidence_Score, and Validation_Flag.</a:t>
+              <a:t>Every record receives Emission_Source_Flag, Emissions_Data_Available_Flag, Data_Quality_Flag, Missing_Parameter_Flag, Confidence_Score, and Validation_Flag.</a:t>
             </a:r>
           </a:p>
         </p:txBody>
@@ -12305,7 +12305,7 @@
                         </a:defRPr>
                       </a:pPr>
                       <a:r>
-                        <a:t>Source used</a:t>
+                        <a:t>Validation item</a:t>
                       </a:r>
                     </a:p>
                   </a:txBody>
@@ -12329,7 +12329,7 @@
                         </a:defRPr>
                       </a:pPr>
                       <a:r>
-                        <a:t>Quality</a:t>
+                        <a:t>Expected result</a:t>
                       </a:r>
                     </a:p>
                   </a:txBody>
@@ -12403,7 +12403,7 @@
                         </a:defRPr>
                       </a:pPr>
                       <a:r>
-                        <a:t>Supplier reported emissions</a:t>
+                        <a:t>Emissions present</a:t>
                       </a:r>
                     </a:p>
                   </a:txBody>
@@ -12427,7 +12427,7 @@
                         </a:defRPr>
                       </a:pPr>
                       <a:r>
-                        <a:t>High</a:t>
+                        <a:t>Total_Emission_Value is populated</a:t>
                       </a:r>
                     </a:p>
                   </a:txBody>
@@ -12475,7 +12475,7 @@
                         </a:defRPr>
                       </a:pPr>
                       <a:r>
-                        <a:t>Preferred supplier disclosure</a:t>
+                        <a:t>Supplier-year can be forecast</a:t>
                       </a:r>
                     </a:p>
                   </a:txBody>
@@ -12501,7 +12501,7 @@
                         </a:defRPr>
                       </a:pPr>
                       <a:r>
-                        <a:t>Scope 1 + Scope 2 + Scope 3</a:t>
+                        <a:t>Non-negative</a:t>
                       </a:r>
                     </a:p>
                   </a:txBody>
@@ -12525,7 +12525,7 @@
                         </a:defRPr>
                       </a:pPr>
                       <a:r>
-                        <a:t>High</a:t>
+                        <a:t>Emissions are &gt;= 0</a:t>
                       </a:r>
                     </a:p>
                   </a:txBody>
@@ -12549,7 +12549,7 @@
                         </a:defRPr>
                       </a:pPr>
                       <a:r>
-                        <a:t>0.88</a:t>
+                        <a:t>0.95</a:t>
                       </a:r>
                     </a:p>
                   </a:txBody>
@@ -12573,7 +12573,7 @@
                         </a:defRPr>
                       </a:pPr>
                       <a:r>
-                        <a:t>Reported components sum to total</a:t>
+                        <a:t>Invalid negative values are blocked</a:t>
                       </a:r>
                     </a:p>
                   </a:txBody>
@@ -12599,7 +12599,7 @@
                         </a:defRPr>
                       </a:pPr>
                       <a:r>
-                        <a:t>Spend-based estimate</a:t>
+                        <a:t>Reasonable range</a:t>
                       </a:r>
                     </a:p>
                   </a:txBody>
@@ -12623,7 +12623,7 @@
                         </a:defRPr>
                       </a:pPr>
                       <a:r>
-                        <a:t>Medium</a:t>
+                        <a:t>No extreme outlier</a:t>
                       </a:r>
                     </a:p>
                   </a:txBody>
@@ -12647,7 +12647,7 @@
                         </a:defRPr>
                       </a:pPr>
                       <a:r>
-                        <a:t>0.70</a:t>
+                        <a:t>0.90</a:t>
                       </a:r>
                     </a:p>
                   </a:txBody>
@@ -12671,7 +12671,7 @@
                         </a:defRPr>
                       </a:pPr>
                       <a:r>
-                        <a:t>Good scalable proxy</a:t>
+                        <a:t>Outliers route to review</a:t>
                       </a:r>
                     </a:p>
                   </a:txBody>
@@ -12697,7 +12697,7 @@
                         </a:defRPr>
                       </a:pPr>
                       <a:r>
-                        <a:t>Revenue-based estimate</a:t>
+                        <a:t>Reporting year present</a:t>
                       </a:r>
                     </a:p>
                   </a:txBody>
@@ -12721,7 +12721,7 @@
                         </a:defRPr>
                       </a:pPr>
                       <a:r>
-                        <a:t>Medium-Low</a:t>
+                        <a:t>Supplier_Year is populated</a:t>
                       </a:r>
                     </a:p>
                   </a:txBody>
@@ -12745,7 +12745,7 @@
                         </a:defRPr>
                       </a:pPr>
                       <a:r>
-                        <a:t>0.60</a:t>
+                        <a:t>0.95</a:t>
                       </a:r>
                     </a:p>
                   </a:txBody>
@@ -12769,7 +12769,7 @@
                         </a:defRPr>
                       </a:pPr>
                       <a:r>
-                        <a:t>Useful when spend is missing</a:t>
+                        <a:t>Trend can be calculated</a:t>
                       </a:r>
                     </a:p>
                   </a:txBody>
@@ -12795,7 +12795,7 @@
                         </a:defRPr>
                       </a:pPr>
                       <a:r>
-                        <a:t>Industry estimate</a:t>
+                        <a:t>Baseline available</a:t>
                       </a:r>
                     </a:p>
                   </a:txBody>
@@ -12819,7 +12819,7 @@
                         </a:defRPr>
                       </a:pPr>
                       <a:r>
-                        <a:t>Low</a:t>
+                        <a:t>Baseline year has emissions</a:t>
                       </a:r>
                     </a:p>
                   </a:txBody>
@@ -12843,7 +12843,7 @@
                         </a:defRPr>
                       </a:pPr>
                       <a:r>
-                        <a:t>0.45</a:t>
+                        <a:t>0.90</a:t>
                       </a:r>
                     </a:p>
                   </a:txBody>
@@ -12867,7 +12867,7 @@
                         </a:defRPr>
                       </a:pPr>
                       <a:r>
-                        <a:t>Last-resort estimate for coverage</a:t>
+                        <a:t>Target pathway can be anchored</a:t>
                       </a:r>
                     </a:p>
                   </a:txBody>
@@ -12917,7 +12917,7 @@
                         </a:defRPr>
                       </a:pPr>
                       <a:r>
-                        <a:t>Missing</a:t>
+                        <a:t>No emissions value</a:t>
                       </a:r>
                     </a:p>
                   </a:txBody>
@@ -13244,7 +13244,7 @@
               </a:defRPr>
             </a:pPr>
             <a:r>
-              <a:t>Use when supplier target is missing but industry pathway assumptions exist.</a:t>
+              <a:t>Use when supplier target is missing but industry target assumptions exist.</a:t>
             </a:r>
           </a:p>
         </p:txBody>

</xml_diff>

<commit_message>
Add emissions benchmark calculations
Co-authored-by: Roja Rao <rojaraod@users.noreply.github.com>
</commit_message>
<xml_diff>
--- a/docs/supply_chain_emissions_forecasting_20_slide_deck.pptx
+++ b/docs/supply_chain_emissions_forecasting_20_slide_deck.pptx
@@ -4390,14 +4390,14 @@
                 <a:gridCol w="5600700"/>
                 <a:gridCol w="5600700"/>
               </a:tblGrid>
-              <a:tr h="634365">
+              <a:tr h="563880">
                 <a:tc>
                   <a:txBody>
                     <a:bodyPr/>
                     <a:lstStyle/>
                     <a:p>
                       <a:pPr>
-                        <a:defRPr b="1" sz="1000">
+                        <a:defRPr b="1" sz="900">
                           <a:solidFill>
                             <a:srgbClr val="FFFFFF"/>
                           </a:solidFill>
@@ -4421,7 +4421,7 @@
                     <a:lstStyle/>
                     <a:p>
                       <a:pPr>
-                        <a:defRPr b="1" sz="1000">
+                        <a:defRPr b="1" sz="900">
                           <a:solidFill>
                             <a:srgbClr val="FFFFFF"/>
                           </a:solidFill>
@@ -4440,14 +4440,14 @@
                   </a:tcPr>
                 </a:tc>
               </a:tr>
-              <a:tr h="634365">
+              <a:tr h="563880">
                 <a:tc>
                   <a:txBody>
                     <a:bodyPr/>
                     <a:lstStyle/>
                     <a:p>
                       <a:pPr>
-                        <a:defRPr sz="1000">
+                        <a:defRPr sz="900">
                           <a:solidFill>
                             <a:srgbClr val="152B4D"/>
                           </a:solidFill>
@@ -4471,7 +4471,7 @@
                     <a:lstStyle/>
                     <a:p>
                       <a:pPr>
-                        <a:defRPr sz="1000">
+                        <a:defRPr sz="900">
                           <a:solidFill>
                             <a:srgbClr val="152B4D"/>
                           </a:solidFill>
@@ -4490,14 +4490,14 @@
                   </a:tcPr>
                 </a:tc>
               </a:tr>
-              <a:tr h="634365">
+              <a:tr h="563880">
                 <a:tc>
                   <a:txBody>
                     <a:bodyPr/>
                     <a:lstStyle/>
                     <a:p>
                       <a:pPr>
-                        <a:defRPr sz="1000">
+                        <a:defRPr sz="900">
                           <a:solidFill>
                             <a:srgbClr val="152B4D"/>
                           </a:solidFill>
@@ -4505,7 +4505,7 @@
                         </a:defRPr>
                       </a:pPr>
                       <a:r>
-                        <a:t>Target emission</a:t>
+                        <a:t>Spend-based emission</a:t>
                       </a:r>
                     </a:p>
                   </a:txBody>
@@ -4521,7 +4521,7 @@
                     <a:lstStyle/>
                     <a:p>
                       <a:pPr>
-                        <a:defRPr sz="1000">
+                        <a:defRPr sz="900">
                           <a:solidFill>
                             <a:srgbClr val="152B4D"/>
                           </a:solidFill>
@@ -4529,7 +4529,7 @@
                         </a:defRPr>
                       </a:pPr>
                       <a:r>
-                        <a:t>Baseline_Emission x (1 - Reduction_Percentage)</a:t>
+                        <a:t>Gross_Spend x Spend_Based_Emission_Factor</a:t>
                       </a:r>
                     </a:p>
                   </a:txBody>
@@ -4540,14 +4540,14 @@
                   </a:tcPr>
                 </a:tc>
               </a:tr>
-              <a:tr h="634365">
+              <a:tr h="563880">
                 <a:tc>
                   <a:txBody>
                     <a:bodyPr/>
                     <a:lstStyle/>
                     <a:p>
                       <a:pPr>
-                        <a:defRPr sz="1000">
+                        <a:defRPr sz="900">
                           <a:solidFill>
                             <a:srgbClr val="152B4D"/>
                           </a:solidFill>
@@ -4555,7 +4555,7 @@
                         </a:defRPr>
                       </a:pPr>
                       <a:r>
-                        <a:t>Annual reduction</a:t>
+                        <a:t>Revenue-based emission</a:t>
                       </a:r>
                     </a:p>
                   </a:txBody>
@@ -4571,7 +4571,7 @@
                     <a:lstStyle/>
                     <a:p>
                       <a:pPr>
-                        <a:defRPr sz="1000">
+                        <a:defRPr sz="900">
                           <a:solidFill>
                             <a:srgbClr val="152B4D"/>
                           </a:solidFill>
@@ -4579,7 +4579,7 @@
                         </a:defRPr>
                       </a:pPr>
                       <a:r>
-                        <a:t>(Baseline_Emission - Target_Emission) / (Target_Year - Baseline_Year)</a:t>
+                        <a:t>Revenue x Revenue_Based_Emission_Intensity</a:t>
                       </a:r>
                     </a:p>
                   </a:txBody>
@@ -4590,14 +4590,14 @@
                   </a:tcPr>
                 </a:tc>
               </a:tr>
-              <a:tr h="634365">
+              <a:tr h="563880">
                 <a:tc>
                   <a:txBody>
                     <a:bodyPr/>
                     <a:lstStyle/>
                     <a:p>
                       <a:pPr>
-                        <a:defRPr sz="1000">
+                        <a:defRPr sz="900">
                           <a:solidFill>
                             <a:srgbClr val="152B4D"/>
                           </a:solidFill>
@@ -4605,7 +4605,7 @@
                         </a:defRPr>
                       </a:pPr>
                       <a:r>
-                        <a:t>Glide path</a:t>
+                        <a:t>Proxy variance</a:t>
                       </a:r>
                     </a:p>
                   </a:txBody>
@@ -4621,7 +4621,7 @@
                     <a:lstStyle/>
                     <a:p>
                       <a:pPr>
-                        <a:defRPr sz="1000">
+                        <a:defRPr sz="900">
                           <a:solidFill>
                             <a:srgbClr val="152B4D"/>
                           </a:solidFill>
@@ -4629,7 +4629,7 @@
                         </a:defRPr>
                       </a:pPr>
                       <a:r>
-                        <a:t>max(Target_Emission, Baseline_Emission - Annual_Reduction x Years_From_Baseline)</a:t>
+                        <a:t>Proxy_Emission - Total_Emission_Value</a:t>
                       </a:r>
                     </a:p>
                   </a:txBody>
@@ -4640,14 +4640,14 @@
                   </a:tcPr>
                 </a:tc>
               </a:tr>
-              <a:tr h="634365">
+              <a:tr h="563880">
                 <a:tc>
                   <a:txBody>
                     <a:bodyPr/>
                     <a:lstStyle/>
                     <a:p>
                       <a:pPr>
-                        <a:defRPr sz="1000">
+                        <a:defRPr sz="900">
                           <a:solidFill>
                             <a:srgbClr val="152B4D"/>
                           </a:solidFill>
@@ -4655,7 +4655,7 @@
                         </a:defRPr>
                       </a:pPr>
                       <a:r>
-                        <a:t>Historical forecast</a:t>
+                        <a:t>Target emission</a:t>
                       </a:r>
                     </a:p>
                   </a:txBody>
@@ -4671,7 +4671,7 @@
                     <a:lstStyle/>
                     <a:p>
                       <a:pPr>
-                        <a:defRPr sz="1000">
+                        <a:defRPr sz="900">
                           <a:solidFill>
                             <a:srgbClr val="152B4D"/>
                           </a:solidFill>
@@ -4679,7 +4679,7 @@
                         </a:defRPr>
                       </a:pPr>
                       <a:r>
-                        <a:t>Latest_Emission x (1 + Historical_CAGR)^Years_After_Latest</a:t>
+                        <a:t>Baseline_Emission x (1 - Reduction_Percentage)</a:t>
                       </a:r>
                     </a:p>
                   </a:txBody>
@@ -4690,14 +4690,14 @@
                   </a:tcPr>
                 </a:tc>
               </a:tr>
-              <a:tr h="634365">
+              <a:tr h="563880">
                 <a:tc>
                   <a:txBody>
                     <a:bodyPr/>
                     <a:lstStyle/>
                     <a:p>
                       <a:pPr>
-                        <a:defRPr sz="1000">
+                        <a:defRPr sz="900">
                           <a:solidFill>
                             <a:srgbClr val="152B4D"/>
                           </a:solidFill>
@@ -4705,7 +4705,7 @@
                         </a:defRPr>
                       </a:pPr>
                       <a:r>
-                        <a:t>Gap to target</a:t>
+                        <a:t>Annual reduction</a:t>
                       </a:r>
                     </a:p>
                   </a:txBody>
@@ -4721,7 +4721,7 @@
                     <a:lstStyle/>
                     <a:p>
                       <a:pPr>
-                        <a:defRPr sz="1000">
+                        <a:defRPr sz="900">
                           <a:solidFill>
                             <a:srgbClr val="152B4D"/>
                           </a:solidFill>
@@ -4729,7 +4729,7 @@
                         </a:defRPr>
                       </a:pPr>
                       <a:r>
-                        <a:t>Forecast_Emission - Target_Emission</a:t>
+                        <a:t>(Baseline_Emission - Target_Emission) / (Target_Year - Baseline_Year)</a:t>
                       </a:r>
                     </a:p>
                   </a:txBody>
@@ -4740,14 +4740,14 @@
                   </a:tcPr>
                 </a:tc>
               </a:tr>
-              <a:tr h="634365">
+              <a:tr h="563880">
                 <a:tc>
                   <a:txBody>
                     <a:bodyPr/>
                     <a:lstStyle/>
                     <a:p>
                       <a:pPr>
-                        <a:defRPr sz="1000">
+                        <a:defRPr sz="900">
                           <a:solidFill>
                             <a:srgbClr val="152B4D"/>
                           </a:solidFill>
@@ -4755,7 +4755,7 @@
                         </a:defRPr>
                       </a:pPr>
                       <a:r>
-                        <a:t>Carbon budget remaining</a:t>
+                        <a:t>Glide path</a:t>
                       </a:r>
                     </a:p>
                   </a:txBody>
@@ -4771,7 +4771,7 @@
                     <a:lstStyle/>
                     <a:p>
                       <a:pPr>
-                        <a:defRPr sz="1000">
+                        <a:defRPr sz="900">
                           <a:solidFill>
                             <a:srgbClr val="152B4D"/>
                           </a:solidFill>
@@ -4779,13 +4779,63 @@
                         </a:defRPr>
                       </a:pPr>
                       <a:r>
-                        <a:t>Target_Carbon_Budget - Cumulative_Emissions</a:t>
+                        <a:t>max(Target_Emission, Baseline_Emission - Annual_Reduction x Years_From_Baseline)</a:t>
                       </a:r>
                     </a:p>
                   </a:txBody>
                   <a:tcPr>
                     <a:solidFill>
                       <a:srgbClr val="FFFFFF"/>
+                    </a:solidFill>
+                  </a:tcPr>
+                </a:tc>
+              </a:tr>
+              <a:tr h="563880">
+                <a:tc>
+                  <a:txBody>
+                    <a:bodyPr/>
+                    <a:lstStyle/>
+                    <a:p>
+                      <a:pPr>
+                        <a:defRPr sz="900">
+                          <a:solidFill>
+                            <a:srgbClr val="152B4D"/>
+                          </a:solidFill>
+                          <a:latin typeface="Aptos"/>
+                        </a:defRPr>
+                      </a:pPr>
+                      <a:r>
+                        <a:t>Historical forecast</a:t>
+                      </a:r>
+                    </a:p>
+                  </a:txBody>
+                  <a:tcPr>
+                    <a:solidFill>
+                      <a:srgbClr val="F2F5F8"/>
+                    </a:solidFill>
+                  </a:tcPr>
+                </a:tc>
+                <a:tc>
+                  <a:txBody>
+                    <a:bodyPr/>
+                    <a:lstStyle/>
+                    <a:p>
+                      <a:pPr>
+                        <a:defRPr sz="900">
+                          <a:solidFill>
+                            <a:srgbClr val="152B4D"/>
+                          </a:solidFill>
+                          <a:latin typeface="Aptos"/>
+                        </a:defRPr>
+                      </a:pPr>
+                      <a:r>
+                        <a:t>Latest_Emission x (1 + Historical_CAGR)^Years_After_Latest</a:t>
+                      </a:r>
+                    </a:p>
+                  </a:txBody>
+                  <a:tcPr>
+                    <a:solidFill>
+                      <a:srgbClr val="F2F5F8"/>
                     </a:solidFill>
                   </a:tcPr>
                 </a:tc>
@@ -4953,7 +5003,7 @@
               <a:spcAft>
                 <a:spcPts val="700"/>
               </a:spcAft>
-              <a:defRPr sz="1600">
+              <a:defRPr sz="1500">
                 <a:solidFill>
                   <a:srgbClr val="152B4D"/>
                 </a:solidFill>
@@ -4969,7 +5019,7 @@
               <a:spcAft>
                 <a:spcPts val="700"/>
               </a:spcAft>
-              <a:defRPr sz="1600">
+              <a:defRPr sz="1500">
                 <a:solidFill>
                   <a:srgbClr val="152B4D"/>
                 </a:solidFill>
@@ -4985,7 +5035,7 @@
               <a:spcAft>
                 <a:spcPts val="700"/>
               </a:spcAft>
-              <a:defRPr sz="1600">
+              <a:defRPr sz="1500">
                 <a:solidFill>
                   <a:srgbClr val="152B4D"/>
                 </a:solidFill>
@@ -5001,7 +5051,7 @@
               <a:spcAft>
                 <a:spcPts val="700"/>
               </a:spcAft>
-              <a:defRPr sz="1600">
+              <a:defRPr sz="1500">
                 <a:solidFill>
                   <a:srgbClr val="152B4D"/>
                 </a:solidFill>
@@ -5009,7 +5059,7 @@
               </a:defRPr>
             </a:pPr>
             <a:r>
-              <a:t>Audit flags: emissions source, data availability, data quality, missing parameters, validation.</a:t>
+              <a:t>Benchmark outputs: spend-based emissions, revenue-based emissions, and variance to actuals.</a:t>
             </a:r>
           </a:p>
           <a:p>
@@ -5017,7 +5067,23 @@
               <a:spcAft>
                 <a:spcPts val="700"/>
               </a:spcAft>
-              <a:defRPr sz="1600">
+              <a:defRPr sz="1500">
+                <a:solidFill>
+                  <a:srgbClr val="152B4D"/>
+                </a:solidFill>
+                <a:latin typeface="Aptos"/>
+              </a:defRPr>
+            </a:pPr>
+            <a:r>
+              <a:t>Audit flags: emissions source, data availability, data quality, missing parameters, validation.</a:t>
+            </a:r>
+          </a:p>
+          <a:p>
+            <a:pPr>
+              <a:spcAft>
+                <a:spcPts val="700"/>
+              </a:spcAft>
+              <a:defRPr sz="1500">
                 <a:solidFill>
                   <a:srgbClr val="152B4D"/>
                 </a:solidFill>
@@ -6161,7 +6227,7 @@
               </a:defRPr>
             </a:pPr>
             <a:r>
-              <a:t>Create quality and source flags</a:t>
+              <a:t>Calculate spend/revenue benchmarks</a:t>
             </a:r>
           </a:p>
         </p:txBody>
@@ -7374,7 +7440,7 @@
                         </a:defRPr>
                       </a:pPr>
                       <a:r>
-                        <a:t>Industry emissions and intensity</a:t>
+                        <a:t>Industry emissions, intensity, spend/revenue variance</a:t>
                       </a:r>
                     </a:p>
                   </a:txBody>
@@ -7398,7 +7464,7 @@
                         </a:defRPr>
                       </a:pPr>
                       <a:r>
-                        <a:t>Which sectors are highest risk?</a:t>
+                        <a:t>Which sectors are highest risk or unusual?</a:t>
                       </a:r>
                     </a:p>
                   </a:txBody>
@@ -7522,7 +7588,7 @@
                         </a:defRPr>
                       </a:pPr>
                       <a:r>
-                        <a:t>Source, availability, missing fields</a:t>
+                        <a:t>Source, availability, proxy variance, missing fields</a:t>
                       </a:r>
                     </a:p>
                   </a:txBody>
@@ -10436,7 +10502,7 @@
               </a:defRPr>
             </a:pPr>
             <a:r>
-              <a:t>Use supplied historical and current emissions</a:t>
+              <a:t>Use supplied historical/current emissions</a:t>
             </a:r>
           </a:p>
         </p:txBody>
@@ -10645,7 +10711,7 @@
               </a:defRPr>
             </a:pPr>
             <a:r>
-              <a:t>Forecast</a:t>
+              <a:t>Benchmarks</a:t>
             </a:r>
           </a:p>
           <a:p>
@@ -10658,7 +10724,7 @@
               </a:defRPr>
             </a:pPr>
             <a:r>
-              <a:t>Target emissions, glide path, gap, budget</a:t>
+              <a:t>Spend-based and revenue-based comparisons</a:t>
             </a:r>
           </a:p>
         </p:txBody>
@@ -10756,7 +10822,7 @@
               </a:defRPr>
             </a:pPr>
             <a:r>
-              <a:t>Outputs</a:t>
+              <a:t>Forecast</a:t>
             </a:r>
           </a:p>
           <a:p>
@@ -10769,14 +10835,125 @@
               </a:defRPr>
             </a:pPr>
             <a:r>
-              <a:t>CSV, Excel, Qlik dashboard, audit flags</a:t>
-            </a:r>
-          </a:p>
-        </p:txBody>
-      </p:sp>
-      <p:sp>
-        <p:nvSpPr>
-          <p:cNvPr id="13" name="TextBox 12"/>
+              <a:t>Target, glide path, gap, budget</a:t>
+            </a:r>
+          </a:p>
+        </p:txBody>
+      </p:sp>
+      <p:sp>
+        <p:nvSpPr>
+          <p:cNvPr id="13" name="Right Arrow 12"/>
+          <p:cNvSpPr/>
+          <p:nvPr/>
+        </p:nvSpPr>
+        <p:spPr>
+          <a:xfrm>
+            <a:off x="9674352" y="2359152"/>
+            <a:ext cx="292608" cy="320040"/>
+          </a:xfrm>
+          <a:prstGeom prst="rightArrow">
+            <a:avLst/>
+          </a:prstGeom>
+          <a:solidFill>
+            <a:srgbClr val="5D6571"/>
+          </a:solidFill>
+          <a:ln>
+            <a:noFill/>
+          </a:ln>
+        </p:spPr>
+        <p:style>
+          <a:lnRef idx="1">
+            <a:schemeClr val="accent1"/>
+          </a:lnRef>
+          <a:fillRef idx="3">
+            <a:schemeClr val="accent1"/>
+          </a:fillRef>
+          <a:effectRef idx="2">
+            <a:schemeClr val="accent1"/>
+          </a:effectRef>
+          <a:fontRef idx="minor">
+            <a:schemeClr val="lt1"/>
+          </a:fontRef>
+        </p:style>
+        <p:txBody>
+          <a:bodyPr rtlCol="0" anchor="ctr"/>
+          <a:lstStyle/>
+          <a:p>
+            <a:pPr algn="ctr"/>
+          </a:p>
+        </p:txBody>
+      </p:sp>
+      <p:sp>
+        <p:nvSpPr>
+          <p:cNvPr id="14" name="Rounded Rectangle 13"/>
+          <p:cNvSpPr/>
+          <p:nvPr/>
+        </p:nvSpPr>
+        <p:spPr>
+          <a:xfrm>
+            <a:off x="9875520" y="1965960"/>
+            <a:ext cx="1691640" cy="1143000"/>
+          </a:xfrm>
+          <a:prstGeom prst="roundRect">
+            <a:avLst/>
+          </a:prstGeom>
+          <a:solidFill>
+            <a:srgbClr val="F2F5F8"/>
+          </a:solidFill>
+          <a:ln>
+            <a:solidFill>
+              <a:srgbClr val="DCE2E8"/>
+            </a:solidFill>
+          </a:ln>
+        </p:spPr>
+        <p:style>
+          <a:lnRef idx="1">
+            <a:schemeClr val="accent1"/>
+          </a:lnRef>
+          <a:fillRef idx="3">
+            <a:schemeClr val="accent1"/>
+          </a:fillRef>
+          <a:effectRef idx="2">
+            <a:schemeClr val="accent1"/>
+          </a:effectRef>
+          <a:fontRef idx="minor">
+            <a:schemeClr val="lt1"/>
+          </a:fontRef>
+        </p:style>
+        <p:txBody>
+          <a:bodyPr rtlCol="0" anchor="ctr" lIns="146304" rIns="146304" tIns="91440" bIns="91440"/>
+          <a:lstStyle/>
+          <a:p>
+            <a:pPr algn="ctr">
+              <a:defRPr sz="1500" b="1">
+                <a:solidFill>
+                  <a:srgbClr val="152B4D"/>
+                </a:solidFill>
+                <a:latin typeface="Aptos"/>
+              </a:defRPr>
+            </a:pPr>
+            <a:r>
+              <a:t>Outputs</a:t>
+            </a:r>
+          </a:p>
+          <a:p>
+            <a:pPr>
+              <a:defRPr sz="1200">
+                <a:solidFill>
+                  <a:srgbClr val="5D6571"/>
+                </a:solidFill>
+                <a:latin typeface="Aptos"/>
+              </a:defRPr>
+            </a:pPr>
+            <a:r>
+              <a:t>CSV, Excel, Qlik dashboard</a:t>
+            </a:r>
+          </a:p>
+        </p:txBody>
+      </p:sp>
+      <p:sp>
+        <p:nvSpPr>
+          <p:cNvPr id="15" name="TextBox 14"/>
           <p:cNvSpPr txBox="1"/>
           <p:nvPr/>
         </p:nvSpPr>
@@ -10831,7 +11008,7 @@
       </p:sp>
       <p:sp>
         <p:nvSpPr>
-          <p:cNvPr id="14" name="TextBox 13"/>
+          <p:cNvPr id="16" name="TextBox 15"/>
           <p:cNvSpPr txBox="1"/>
           <p:nvPr/>
         </p:nvSpPr>
@@ -11962,7 +12139,7 @@
               </a:defRPr>
             </a:pPr>
             <a:r>
-              <a:t>Flag outliers</a:t>
+              <a:t>Calculate proxy benchmarks</a:t>
             </a:r>
           </a:p>
         </p:txBody>
@@ -12073,7 +12250,7 @@
               </a:defRPr>
             </a:pPr>
             <a:r>
-              <a:t>Use in forecast</a:t>
+              <a:t>Use actuals in forecast</a:t>
             </a:r>
           </a:p>
         </p:txBody>
@@ -12104,7 +12281,7 @@
               <a:spcAft>
                 <a:spcPts val="700"/>
               </a:spcAft>
-              <a:defRPr sz="1600">
+              <a:defRPr sz="1500">
                 <a:solidFill>
                   <a:srgbClr val="152B4D"/>
                 </a:solidFill>
@@ -12120,7 +12297,23 @@
               <a:spcAft>
                 <a:spcPts val="700"/>
               </a:spcAft>
-              <a:defRPr sz="1600">
+              <a:defRPr sz="1500">
+                <a:solidFill>
+                  <a:srgbClr val="152B4D"/>
+                </a:solidFill>
+                <a:latin typeface="Aptos"/>
+              </a:defRPr>
+            </a:pPr>
+            <a:r>
+              <a:t>Spend-based and revenue-based emissions are added as benchmark checks against actual emissions.</a:t>
+            </a:r>
+          </a:p>
+          <a:p>
+            <a:pPr>
+              <a:spcAft>
+                <a:spcPts val="700"/>
+              </a:spcAft>
+              <a:defRPr sz="1500">
                 <a:solidFill>
                   <a:srgbClr val="152B4D"/>
                 </a:solidFill>

</xml_diff>